<commit_message>
W01 D5: rehearsal round one sums to 50 minutes with the modelled push inside it, the monsoon push is off pair one's list with its follow-ups in the key, 'half' where the brief said 'mostly', S12 names the Kahoot's four design calls, and crux line 4 keeps each customer's own two quarters together
Co-Authored-By: Claude Opus 5.5 <noreply@anthropic.com>
Claude-Session: https://claude.ai/code/session_01P7zaoR4dQ5pzBFnsX549JQ
</commit_message>
<xml_diff>
--- a/content/W01/D5/slides/C2_W01_D05_rehearsal_STUDENT.pptx
+++ b/content/W01/D5/slides/C2_W01_D05_rehearsal_STUDENT.pptx
@@ -755,12 +755,17 @@
           <a:lstStyle/>
           <a:p>
             <a:r>
-              <a:t>LIVE, 13 minutes. Listen for the options sized against the two hours, for the reconciliation named</a:t>
-            </a:r>
-          </a:p>
-          <a:p>
-            <a:r>
-              <a:t>as the step never dropped, and for the fact that would switch the plan.</a:t>
+              <a:t>LIVE, 13 minutes. Listen for every plan sized from the lab's pace (all four cost between 95 and 105</a:t>
+            </a:r>
+          </a:p>
+          <a:p>
+            <a:r>
+              <a:t>minutes, so the clock does not choose), for the reconciliation named as the step never dropped, and</a:t>
+            </a:r>
+          </a:p>
+          <a:p>
+            <a:r>
+              <a:t>for the fact that would switch the plan.</a:t>
             </a:r>
           </a:p>
         </p:txBody>
@@ -1430,7 +1435,7 @@
           <a:lstStyle/>
           <a:p>
             <a:r>
-              <a:t>LIVE, 3 minutes. Name the four and the one thing each listens for. The note being rehearsed is the</a:t>
+              <a:t>LIVE, 2 minutes. Name the four and the one thing each listens for. The note being rehearsed is the</a:t>
             </a:r>
           </a:p>
           <a:p>
@@ -1510,7 +1515,7 @@
           <a:lstStyle/>
           <a:p>
             <a:r>
-              <a:t>LIVE, 2 minutes. The timings add to two minutes. A learner who runs long almost always ran long in</a:t>
+              <a:t>LIVE, 1 minute. The timings add to two minutes. A learner who runs long almost always ran long in</a:t>
             </a:r>
           </a:p>
           <a:p>
@@ -1595,12 +1600,12 @@
           </a:p>
           <a:p>
             <a:r>
-              <a:t>The first push is the sharpest: the brief answers it in full, and a TA reads Marketing's lines while</a:t>
-            </a:r>
-          </a:p>
-          <a:p>
-            <a:r>
-              <a:t>you model the answer once.</a:t>
+              <a:t>The first push is the sharpest: the brief answers it in full, and after S6 a TA reads Marketing's</a:t>
+            </a:r>
+          </a:p>
+          <a:p>
+            <a:r>
+              <a:t>lines while you model the answer once, in four minutes. It is on neither pair list.</a:t>
             </a:r>
           </a:p>
         </p:txBody>
@@ -1670,7 +1675,7 @@
           <a:lstStyle/>
           <a:p>
             <a:r>
-              <a:t>LIVE, 3 minutes. Demonstrate the three moves once with a volunteer playing Marketing on the</a:t>
+              <a:t>LIVE, 2 minutes. Demonstrate the three moves once with a volunteer playing Marketing on the</a:t>
             </a:r>
           </a:p>
           <a:p>
@@ -1750,7 +1755,12 @@
           <a:lstStyle/>
           <a:p>
             <a:r>
-              <a:t>LIVE, 50 minutes, of which S1 to S4 and S6 took the first six. The TAs walk the room. Each TA also uses this round to tell each of their learners,</a:t>
+              <a:t>LIVE, 50 minutes: S1 to S4 and S6 take eight, Marketing's sharpest push, modelled once with a TA,</a:t>
+            </a:r>
+          </a:p>
+          <a:p>
+            <a:r>
+              <a:t>takes four, and the pairs take the other 38. The TAs walk the room. Each TA also uses this round to tell each of their learners,</a:t>
             </a:r>
           </a:p>
           <a:p>
@@ -5994,7 +6004,7 @@
                 </a:solidFill>
                 <a:latin typeface="Calibri"/>
               </a:rPr>
-              <a:t>Week 1 Day 5: the week rebuilt alone</a:t>
+              <a:t>Week 1, Day 5. The note, defended aloud</a:t>
             </a:r>
           </a:p>
         </p:txBody>
@@ -7830,7 +7840,7 @@
                 </a:solidFill>
                 <a:latin typeface="Calibri"/>
               </a:rPr>
-              <a:t>A raw export, a review on Monday, and four plans that fit the clock differently.</a:t>
+              <a:t>A raw export, a review on Monday, and four plans that each fit the clock and each leave a step out.</a:t>
             </a:r>
           </a:p>
         </p:txBody>
@@ -8021,14 +8031,14 @@
                 </a:solidFill>
                 <a:latin typeface="Calibri"/>
               </a:rPr>
-              <a:t>[F] You have two hours and a raw export; what do you do first, and what do you skip? Here the export is Q3 from the ERP, and DMart is the likeness: it publishes a provisional quarter days before its board signs the results.</a:t>
+              <a:t>[F] You have two hours and a raw export; what do you do first, and what do you skip? Here the export is Q3 from the ERP, and DMart is the likeness: it publishes a provisional quarter days before it files the results.</a:t>
             </a:r>
           </a:p>
         </p:txBody>
       </p:sp>
       <p:pic>
         <p:nvPicPr>
-          <p:cNvPr id="14" name="mermaid diagram" descr="2e76e40b7f31703c.png"/>
+          <p:cNvPr id="14" name="mermaid diagram" descr="bf8c3587e8789414.png"/>
           <p:cNvPicPr>
             <a:picLocks noChangeAspect="1"/>
           </p:cNvPicPr>
@@ -8042,8 +8052,8 @@
         </p:blipFill>
         <p:spPr>
           <a:xfrm>
-            <a:off x="530352" y="3502152"/>
-            <a:ext cx="11130991" cy="2055548"/>
+            <a:off x="1638147" y="3502152"/>
+            <a:ext cx="8915400" cy="2271712"/>
           </a:xfrm>
           <a:prstGeom prst="rect">
             <a:avLst/>
@@ -8572,7 +8582,7 @@
         <p:spPr>
           <a:xfrm>
             <a:off x="530352" y="1956816"/>
-            <a:ext cx="11130991" cy="1121664"/>
+            <a:ext cx="11130991" cy="1380744"/>
           </a:xfrm>
           <a:prstGeom prst="roundRect">
             <a:avLst>
@@ -8625,7 +8635,7 @@
         </p:nvSpPr>
         <p:spPr>
           <a:xfrm>
-            <a:off x="758952" y="2289048"/>
+            <a:off x="758952" y="2418588"/>
             <a:ext cx="457200" cy="457200"/>
           </a:xfrm>
           <a:prstGeom prst="ellipse">
@@ -8677,7 +8687,7 @@
         </p:blipFill>
         <p:spPr>
           <a:xfrm>
-            <a:off x="868680" y="2398776"/>
+            <a:off x="868680" y="2528316"/>
             <a:ext cx="237744" cy="237744"/>
           </a:xfrm>
           <a:prstGeom prst="rect">
@@ -8729,7 +8739,7 @@
         <p:spPr>
           <a:xfrm>
             <a:off x="1399031" y="2322576"/>
-            <a:ext cx="9987991" cy="682752"/>
+            <a:ext cx="9987991" cy="941832"/>
           </a:xfrm>
           <a:prstGeom prst="rect">
             <a:avLst/>
@@ -8749,7 +8759,7 @@
                 </a:solidFill>
                 <a:latin typeface="Calibri"/>
               </a:rPr>
-              <a:t>[S] Walk me through how you clean and check a dataset you have never seen. Here four checks cost from seconds to a day, and TSB is the likeness: a migrated platform trusted before it was reconciled.</a:t>
+              <a:t>[S] Walk me through how you clean and check a dataset you have never seen. Here four checks cost from seconds to a day, and TSB is a loose likeness: a new platform whose output was trusted before it was checked.</a:t>
             </a:r>
           </a:p>
         </p:txBody>
@@ -8762,7 +8772,7 @@
         </p:nvSpPr>
         <p:spPr>
           <a:xfrm>
-            <a:off x="530352" y="3243072"/>
+            <a:off x="530352" y="3502152"/>
             <a:ext cx="3527450" cy="698500"/>
           </a:xfrm>
           <a:prstGeom prst="rect">
@@ -8797,7 +8807,7 @@
         </p:nvSpPr>
         <p:spPr>
           <a:xfrm>
-            <a:off x="530352" y="3978148"/>
+            <a:off x="530352" y="4237228"/>
             <a:ext cx="3527450" cy="168656"/>
           </a:xfrm>
           <a:prstGeom prst="rect">
@@ -8832,7 +8842,7 @@
         </p:nvSpPr>
         <p:spPr>
           <a:xfrm>
-            <a:off x="530352" y="4179316"/>
+            <a:off x="530352" y="4438396"/>
             <a:ext cx="3527450" cy="193421"/>
           </a:xfrm>
           <a:prstGeom prst="rect">
@@ -8867,7 +8877,7 @@
         </p:nvSpPr>
         <p:spPr>
           <a:xfrm>
-            <a:off x="530352" y="4431792"/>
+            <a:off x="530352" y="4690872"/>
             <a:ext cx="3527450" cy="10972"/>
           </a:xfrm>
           <a:prstGeom prst="rect">
@@ -8911,7 +8921,7 @@
         </p:nvSpPr>
         <p:spPr>
           <a:xfrm>
-            <a:off x="4332122" y="3243072"/>
+            <a:off x="4332122" y="3502152"/>
             <a:ext cx="3527450" cy="698500"/>
           </a:xfrm>
           <a:prstGeom prst="rect">
@@ -8946,7 +8956,7 @@
         </p:nvSpPr>
         <p:spPr>
           <a:xfrm>
-            <a:off x="4332122" y="3978148"/>
+            <a:off x="4332122" y="4237228"/>
             <a:ext cx="3527450" cy="168656"/>
           </a:xfrm>
           <a:prstGeom prst="rect">
@@ -8981,7 +8991,7 @@
         </p:nvSpPr>
         <p:spPr>
           <a:xfrm>
-            <a:off x="4332122" y="4179316"/>
+            <a:off x="4332122" y="4438396"/>
             <a:ext cx="3527450" cy="193421"/>
           </a:xfrm>
           <a:prstGeom prst="rect">
@@ -9016,7 +9026,7 @@
         </p:nvSpPr>
         <p:spPr>
           <a:xfrm>
-            <a:off x="4332122" y="4431792"/>
+            <a:off x="4332122" y="4690872"/>
             <a:ext cx="3527450" cy="10972"/>
           </a:xfrm>
           <a:prstGeom prst="rect">
@@ -9060,7 +9070,7 @@
         </p:nvSpPr>
         <p:spPr>
           <a:xfrm>
-            <a:off x="8133892" y="3243072"/>
+            <a:off x="8133892" y="3502152"/>
             <a:ext cx="3527450" cy="698500"/>
           </a:xfrm>
           <a:prstGeom prst="rect">
@@ -9095,7 +9105,7 @@
         </p:nvSpPr>
         <p:spPr>
           <a:xfrm>
-            <a:off x="8133892" y="3978148"/>
+            <a:off x="8133892" y="4237228"/>
             <a:ext cx="3527450" cy="168656"/>
           </a:xfrm>
           <a:prstGeom prst="rect">
@@ -9130,7 +9140,7 @@
         </p:nvSpPr>
         <p:spPr>
           <a:xfrm>
-            <a:off x="8133892" y="4179316"/>
+            <a:off x="8133892" y="4438396"/>
             <a:ext cx="3527450" cy="193421"/>
           </a:xfrm>
           <a:prstGeom prst="rect">
@@ -9165,7 +9175,7 @@
         </p:nvSpPr>
         <p:spPr>
           <a:xfrm>
-            <a:off x="8133892" y="4431792"/>
+            <a:off x="8133892" y="4690872"/>
             <a:ext cx="3527450" cy="10972"/>
           </a:xfrm>
           <a:prstGeom prst="rect">
@@ -11095,7 +11105,7 @@
                 </a:solidFill>
                 <a:latin typeface="Calibri"/>
               </a:rPr>
-              <a:t>Week 1 Day 5: the week rebuilt alone</a:t>
+              <a:t>Week 1, Day 5. The note, defended aloud</a:t>
             </a:r>
           </a:p>
         </p:txBody>
@@ -11371,14 +11381,14 @@
                 </a:solidFill>
                 <a:latin typeface="Calibri"/>
               </a:rPr>
-              <a:t>Five on the method, two design calls and Thursday's return question, ungraded.</a:t>
+              <a:t>Three on the method, four design calls and Thursday's return question, ungraded.</a:t>
             </a:r>
           </a:p>
         </p:txBody>
       </p:sp>
       <p:pic>
         <p:nvPicPr>
-          <p:cNvPr id="9" name="mermaid diagram" descr="11a77ed4f1c2fc56.png"/>
+          <p:cNvPr id="9" name="mermaid diagram" descr="c5810a2e86732992.png"/>
           <p:cNvPicPr>
             <a:picLocks noChangeAspect="1"/>
           </p:cNvPicPr>
@@ -11392,8 +11402,8 @@
         </p:blipFill>
         <p:spPr>
           <a:xfrm>
-            <a:off x="1466697" y="1956816"/>
-            <a:ext cx="9258300" cy="1628775"/>
+            <a:off x="1888178" y="1956816"/>
+            <a:ext cx="8415337" cy="1628775"/>
           </a:xfrm>
           <a:prstGeom prst="rect">
             <a:avLst/>
@@ -13605,7 +13615,7 @@
                 </a:solidFill>
                 <a:latin typeface="Calibri"/>
               </a:rPr>
-              <a:t>Shuffle what belongs together, which this week is the customer.</a:t>
+              <a:t>Keep each customer's own two quarters together in every shuffle.</a:t>
             </a:r>
           </a:p>
         </p:txBody>
@@ -15779,7 +15789,7 @@
                 </a:solidFill>
                 <a:latin typeface="Calibri"/>
               </a:rPr>
-              <a:t>Week 1 Day 5: the week rebuilt alone</a:t>
+              <a:t>Week 1, Day 5. The note, defended aloud</a:t>
             </a:r>
           </a:p>
         </p:txBody>
@@ -20539,7 +20549,7 @@
       </p:sp>
       <p:pic>
         <p:nvPicPr>
-          <p:cNvPr id="9" name="mermaid diagram" descr="979168cf41283807.png"/>
+          <p:cNvPr id="9" name="mermaid diagram" descr="ea3b488851d317b9.png"/>
           <p:cNvPicPr>
             <a:picLocks noChangeAspect="1"/>
           </p:cNvPicPr>
@@ -20553,8 +20563,8 @@
         </p:blipFill>
         <p:spPr>
           <a:xfrm>
-            <a:off x="1759591" y="1956816"/>
-            <a:ext cx="8672512" cy="1128712"/>
+            <a:off x="1123797" y="1956816"/>
+            <a:ext cx="9944100" cy="1128712"/>
           </a:xfrm>
           <a:prstGeom prst="rect">
             <a:avLst/>
@@ -20595,7 +20605,7 @@
                 </a:solidFill>
                 <a:latin typeface="Calibri"/>
               </a:rPr>
-              <a:t>In pair one each twelve minutes runs: two minutes of the note read aloud, six of pushes and answers, four for the partner to fill the feedback card. Pair two takes ten: two, five and three.</a:t>
+              <a:t>In pair one each ten minutes runs: two minutes of the note read aloud, five of pushes and answers, three for the partner to fill the feedback card. Pair two takes nine: two, four and three.</a:t>
             </a:r>
           </a:p>
         </p:txBody>

</xml_diff>

<commit_message>
W01 D5: the rehearsal runs its modelled push on invented figures, and the key reruns Thursday's test the fair way
The brief's modelled push uses an invented blend in place of Thursday's planted monsoon values, a new
push joins pair two, and the key adds this morning's paired, both-ways test on Thursday's orders
(p = 0.052) with the line a trainer says when a note quotes Thursday's 0.027. The deck's minutes add
up to the slot, and the day sheet's push line names the invented figures and their real ones.

Co-Authored-By: Claude Opus 5.5 <noreply@anthropic.com>
Claude-Session: https://claude.ai/code/session_01SjahrTf7jZ3ViL54dzqiBa
</commit_message>
<xml_diff>
--- a/content/W01/D5/slides/C2_W01_D05_rehearsal_STUDENT.pptx
+++ b/content/W01/D5/slides/C2_W01_D05_rehearsal_STUDENT.pptx
@@ -528,7 +528,7 @@
           <a:lstStyle/>
           <a:p>
             <a:r>
-              <a:t>LIVE, one minute. The afternoon, after the debrief's second half: the rehearsal in two rounds (100</a:t>
+              <a:t>LIVE, inside S1's half minute. The afternoon, after the debrief's second half: the rehearsal in two rounds (100</a:t>
             </a:r>
           </a:p>
           <a:p>
@@ -608,12 +608,12 @@
           <a:lstStyle/>
           <a:p>
             <a:r>
-              <a:t>LIVE, 50 minutes: S1 to S6 and S9 take eight, Marketing's sharpest push, modelled once with a TA,</a:t>
-            </a:r>
-          </a:p>
-          <a:p>
-            <a:r>
-              <a:t>takes four, and the pairs take the other 38. The TAs walk the room. Each TA also uses this round to</a:t>
+              <a:t>LIVE, 50 minutes: S1 to S6 and S9 take eight, Marketing's sharpest push, modelled once at S7 with a</a:t>
+            </a:r>
+          </a:p>
+          <a:p>
+            <a:r>
+              <a:t>TA, takes four, and the pairs take the other 38. The TAs walk the room. Each TA also uses this round to</a:t>
             </a:r>
           </a:p>
           <a:p>
@@ -923,7 +923,7 @@
           <a:lstStyle/>
           <a:p>
             <a:r>
-              <a:t>LIVE, 1 minute. Read who needs the answer and the three cases.</a:t>
+              <a:t>LIVE, half a minute. Read who needs the answer and the three cases.</a:t>
             </a:r>
           </a:p>
         </p:txBody>
@@ -993,7 +993,7 @@
           <a:lstStyle/>
           <a:p>
             <a:r>
-              <a:t>LIVE, 1 minute. The prompts are in exercises/unguided/C2_W01_D05_timed_cases_STUDENT.md. The model</a:t>
+              <a:t>LIVE, half a minute. The prompts are in exercises/unguided/C2_W01_D05_timed_cases_STUDENT.md. The model</a:t>
             </a:r>
           </a:p>
           <a:p>
@@ -1958,7 +1958,7 @@
           <a:lstStyle/>
           <a:p>
             <a:r>
-              <a:t>LIVE, 4 minutes. Close on the three tasks. The practice set is in exercises/practice/ and the TAs</a:t>
+              <a:t>LIVE, 3 and a half minutes. Close on the three tasks. The practice set is in exercises/practice/ and the TAs</a:t>
             </a:r>
           </a:p>
           <a:p>
@@ -2178,7 +2178,7 @@
           <a:lstStyle/>
           <a:p>
             <a:r>
-              <a:t>LIVE, 2 minutes. Name the four and the one thing each listens for. The note being rehearsed is the</a:t>
+              <a:t>LIVE, 1 minute. Name the four and the one thing each listens for. The note being rehearsed is the</a:t>
             </a:r>
           </a:p>
           <a:p>
@@ -2348,12 +2348,12 @@
           </a:p>
           <a:p>
             <a:r>
-              <a:t>is the sharpest: the brief answers it in full, and after S7 a TA reads Marketing's lines while you</a:t>
-            </a:r>
-          </a:p>
-          <a:p>
-            <a:r>
-              <a:t>model the answer once, in four minutes. It is on neither pair list.</a:t>
+              <a:t>is the sharpest: the brief answers it in full on invented figures, and at S7 a TA reads Marketing's</a:t>
+            </a:r>
+          </a:p>
+          <a:p>
+            <a:r>
+              <a:t>lines while you model the answer once, in four minutes. It is on neither pair list.</a:t>
             </a:r>
           </a:p>
         </p:txBody>
@@ -2503,17 +2503,32 @@
           <a:lstStyle/>
           <a:p>
             <a:r>
-              <a:t>LIVE, 4 minutes: the modelled push. A TA reads Marketing's lines from the rehearsal brief, the</a:t>
-            </a:r>
-          </a:p>
-          <a:p>
-            <a:r>
-              <a:t>monsoon sale's two averages, and you answer once in the three moves, using the segment table the</a:t>
-            </a:r>
-          </a:p>
-          <a:p>
-            <a:r>
-              <a:t>brief prints. The brief carries the answer in full; this slide is its shape.</a:t>
+              <a:t>LIVE, 4 minutes: the modelled push. A TA reads Marketing's lines from the rehearsal brief, whose</a:t>
+            </a:r>
+          </a:p>
+          <a:p>
+            <a:r>
+              <a:t>invented averages are Rs 3,040 for the 60 customers who got the sale against Rs 2,900 for the 100</a:t>
+            </a:r>
+          </a:p>
+          <a:p>
+            <a:r>
+              <a:t>who did not, and you answer once in the three moves from the brief's invented segment table:</a:t>
+            </a:r>
+          </a:p>
+          <a:p>
+            <a:r>
+              <a:t>members Rs 3,990 against Rs 4,200 and Retail-Core Rs 2,090 against Rs 2,200, 5.0 percent less in</a:t>
+            </a:r>
+          </a:p>
+          <a:p>
+            <a:r>
+              <a:t>each. Say once that the figures are invented and that each defender's note carries Thursday's real</a:t>
+            </a:r>
+          </a:p>
+          <a:p>
+            <a:r>
+              <a:t>ones, which the same answer fits. The brief carries the answer in full; this slide is its shape.</a:t>
             </a:r>
           </a:p>
         </p:txBody>
@@ -7387,7 +7402,7 @@
                 </a:solidFill>
                 <a:latin typeface="Calibri"/>
               </a:rPr>
-              <a:t>Said before the push, after it, or not at all?</a:t>
+              <a:t>Was it said before the push, after it, or not at all?</a:t>
             </a:r>
           </a:p>
         </p:txBody>
@@ -7841,7 +7856,7 @@
                 </a:solidFill>
                 <a:latin typeface="Calibri"/>
               </a:rPr>
-              <a:t>One sentence to keep, one to cut.</a:t>
+              <a:t>Name one sentence to keep and one to cut.</a:t>
             </a:r>
           </a:p>
         </p:txBody>
@@ -9480,7 +9495,7 @@
                 </a:solidFill>
                 <a:latin typeface="Calibri"/>
               </a:rPr>
-              <a:t>Who needs this answer, and which cases lead to it?</a:t>
+              <a:t>Who acts on the approach you pick, and which three cases test it?</a:t>
             </a:r>
           </a:p>
         </p:txBody>
@@ -9864,7 +9879,7 @@
                 </a:solidFill>
                 <a:latin typeface="Calibri"/>
               </a:rPr>
-              <a:t>Meera's first read in two hours.</a:t>
+              <a:t>Meera wants a first read in two hours.</a:t>
             </a:r>
           </a:p>
         </p:txBody>
@@ -10067,7 +10082,7 @@
                 </a:solidFill>
                 <a:latin typeface="Calibri"/>
               </a:rPr>
-              <a:t>Zero rejects and a Rs 20 lakh gap.</a:t>
+              <a:t>Zero rejects meet a Rs 20 lakh gap.</a:t>
             </a:r>
           </a:p>
         </p:txBody>
@@ -10241,7 +10256,7 @@
                 </a:solidFill>
                 <a:latin typeface="Calibri"/>
               </a:rPr>
-              <a:t>Can 12 visits beat 1,200?</a:t>
+              <a:t>Can 5 of 12 beat 31 percent?</a:t>
             </a:r>
           </a:p>
         </p:txBody>
@@ -10276,7 +10291,7 @@
                 </a:solidFill>
                 <a:latin typeface="Calibri"/>
               </a:rPr>
-              <a:t>42 percent on twelve visits.</a:t>
+              <a:t>The product head wants to ship on 42 percent.</a:t>
             </a:r>
           </a:p>
         </p:txBody>
@@ -11036,7 +11051,7 @@
                 </a:solidFill>
                 <a:latin typeface="Calibri"/>
               </a:rPr>
-              <a:t>The case, its options and the real company it is like.</a:t>
+              <a:t>Read the case, its options and the real company it is like.</a:t>
             </a:r>
           </a:p>
         </p:txBody>
@@ -11239,7 +11254,7 @@
                 </a:solidFill>
                 <a:latin typeface="Calibri"/>
               </a:rPr>
-              <a:t>On paper: which option fits, sized how, and what would switch it.</a:t>
+              <a:t>On paper, pick an option, size it, and name what would switch it.</a:t>
             </a:r>
           </a:p>
         </p:txBody>
@@ -11421,7 +11436,7 @@
         <p:spPr>
           <a:xfrm>
             <a:off x="6351879" y="3277870"/>
-            <a:ext cx="2316403" cy="201676"/>
+            <a:ext cx="2316403" cy="366776"/>
           </a:xfrm>
           <a:prstGeom prst="rect">
             <a:avLst/>
@@ -11442,7 +11457,7 @@
                 </a:solidFill>
                 <a:latin typeface="Calibri"/>
               </a:rPr>
-              <a:t>Two minutes each, to your partner.</a:t>
+              <a:t>Each of you answers your partner for two minutes.</a:t>
             </a:r>
           </a:p>
         </p:txBody>
@@ -11645,7 +11660,7 @@
                 </a:solidFill>
                 <a:latin typeface="Calibri"/>
               </a:rPr>
-              <a:t>Two answers to the room, then the model answer.</a:t>
+              <a:t>Two answers go to the room, then the model answer.</a:t>
             </a:r>
           </a:p>
         </p:txBody>
@@ -12363,7 +12378,7 @@
         <p:spPr>
           <a:xfrm>
             <a:off x="530352" y="1956816"/>
-            <a:ext cx="11130991" cy="807720"/>
+            <a:ext cx="11130991" cy="1074420"/>
           </a:xfrm>
           <a:prstGeom prst="roundRect">
             <a:avLst>
@@ -12411,7 +12426,7 @@
         <p:spPr>
           <a:xfrm>
             <a:off x="676656" y="2084832"/>
-            <a:ext cx="45720" cy="551688"/>
+            <a:ext cx="45720" cy="818388"/>
           </a:xfrm>
           <a:prstGeom prst="roundRect">
             <a:avLst>
@@ -12457,7 +12472,7 @@
         <p:spPr>
           <a:xfrm>
             <a:off x="877824" y="2075688"/>
-            <a:ext cx="10564063" cy="624840"/>
+            <a:ext cx="10564063" cy="891540"/>
           </a:xfrm>
           <a:prstGeom prst="rect">
             <a:avLst/>
@@ -12486,7 +12501,7 @@
                 </a:solidFill>
                 <a:latin typeface="Calibri"/>
               </a:rPr>
-              <a:t>Each plan fits the clock at the lab's pace. Choose one: a) no reconciliation; b) no test, the note marked provisional; c) the tree and a test for one segment only; d) no profile, straight to cleaning.</a:t>
+              <a:t>Each plan fits the clock at the lab's pace. Choose one: a) no reconciliation; b) no test, the note marked provisional; c) no tree: one segment's gap tested, with the note on that segment; d) no profile, straight to cleaning.</a:t>
             </a:r>
           </a:p>
         </p:txBody>
@@ -12499,7 +12514,7 @@
         </p:nvSpPr>
         <p:spPr>
           <a:xfrm>
-            <a:off x="530352" y="2929128"/>
+            <a:off x="530352" y="3195828"/>
             <a:ext cx="11130991" cy="1380744"/>
           </a:xfrm>
           <a:prstGeom prst="roundRect">
@@ -12553,7 +12568,7 @@
         </p:nvSpPr>
         <p:spPr>
           <a:xfrm>
-            <a:off x="758952" y="3390900"/>
+            <a:off x="758952" y="3657600"/>
             <a:ext cx="457200" cy="457200"/>
           </a:xfrm>
           <a:prstGeom prst="ellipse">
@@ -12605,7 +12620,7 @@
         </p:blipFill>
         <p:spPr>
           <a:xfrm>
-            <a:off x="868680" y="3500628"/>
+            <a:off x="868680" y="3767328"/>
             <a:ext cx="237744" cy="237744"/>
           </a:xfrm>
           <a:prstGeom prst="rect">
@@ -12621,7 +12636,7 @@
         </p:nvSpPr>
         <p:spPr>
           <a:xfrm>
-            <a:off x="1399031" y="3075432"/>
+            <a:off x="1399031" y="3342132"/>
             <a:ext cx="9987991" cy="160401"/>
           </a:xfrm>
           <a:prstGeom prst="rect">
@@ -12656,7 +12671,7 @@
         </p:nvSpPr>
         <p:spPr>
           <a:xfrm>
-            <a:off x="1399031" y="3294888"/>
+            <a:off x="1399031" y="3561588"/>
             <a:ext cx="9987991" cy="941832"/>
           </a:xfrm>
           <a:prstGeom prst="rect">
@@ -13155,7 +13170,7 @@
                 </a:solidFill>
                 <a:latin typeface="Georgia"/>
               </a:rPr>
-              <a:t>Answer: leave out the test, never the reconciliation</a:t>
+              <a:t>Answer: keep the reconciliation, leave out the test</a:t>
             </a:r>
           </a:p>
         </p:txBody>
@@ -13479,7 +13494,7 @@
                           </a:solidFill>
                           <a:latin typeface="Calibri"/>
                         </a:rPr>
-                        <a:t>Every segment but one</a:t>
+                        <a:t>The tree: one segment's gap is tested with no decomposition</a:t>
                       </a:r>
                     </a:p>
                   </a:txBody>
@@ -14398,7 +14413,7 @@
                 </a:solidFill>
                 <a:latin typeface="Calibri"/>
               </a:rPr>
-              <a:t>About 50,000 rows. Choose the order: a) the ledger match first, since it names every order; b) ids against rows and the value accounting, then a monthly bridge; c) the monthly bridge first, then ids against rows; d) the dashboard's own query, since it ran for years.</a:t>
+              <a:t>About 50,000 rows. Choose the order: a) the ledger match first, since it names every order; b) ids against rows and the value accounting, then a monthly bridge; c) the monthly bridge first, then ids against rows once the gap is sized; d) the dashboard's own query first, since the dashboard has run for years.</a:t>
             </a:r>
           </a:p>
         </p:txBody>
@@ -14412,7 +14427,7 @@
         <p:spPr>
           <a:xfrm>
             <a:off x="530352" y="3195828"/>
-            <a:ext cx="11130991" cy="1121664"/>
+            <a:ext cx="11130991" cy="1380744"/>
           </a:xfrm>
           <a:prstGeom prst="roundRect">
             <a:avLst>
@@ -14465,7 +14480,7 @@
         </p:nvSpPr>
         <p:spPr>
           <a:xfrm>
-            <a:off x="758952" y="3528060"/>
+            <a:off x="758952" y="3657600"/>
             <a:ext cx="457200" cy="457200"/>
           </a:xfrm>
           <a:prstGeom prst="ellipse">
@@ -14517,7 +14532,7 @@
         </p:blipFill>
         <p:spPr>
           <a:xfrm>
-            <a:off x="868680" y="3637788"/>
+            <a:off x="868680" y="3767328"/>
             <a:ext cx="237744" cy="237744"/>
           </a:xfrm>
           <a:prstGeom prst="rect">
@@ -14569,7 +14584,7 @@
         <p:spPr>
           <a:xfrm>
             <a:off x="1399031" y="3561588"/>
-            <a:ext cx="9987991" cy="682752"/>
+            <a:ext cx="9987991" cy="941832"/>
           </a:xfrm>
           <a:prstGeom prst="rect">
             <a:avLst/>
@@ -14589,7 +14604,7 @@
                 </a:solidFill>
                 <a:latin typeface="Calibri"/>
               </a:rPr>
-              <a:t>[S] Walk me through how you clean and check a dataset you have never seen. TSB is a loose likeness: a new platform whose output was trusted before it was checked.</a:t>
+              <a:t>[S] Walk me through how you clean and check a dataset you have never seen. TSB is a loose likeness: its customers were locked out of a new platform, where this case is a total trusted before it was reconciled.</a:t>
             </a:r>
           </a:p>
         </p:txBody>
@@ -16173,7 +16188,7 @@
                 </a:solidFill>
                 <a:latin typeface="Calibri"/>
               </a:rPr>
-              <a:t>Does your note hold when Marketing pushes, and what do you do when the clock runs?</a:t>
+              <a:t>Does your note hold when Marketing pushes, which approach fits each case, and what is yours now?</a:t>
             </a:r>
           </a:p>
         </p:txBody>
@@ -16420,7 +16435,7 @@
                 </a:solidFill>
                 <a:latin typeface="Calibri"/>
               </a:rPr>
-              <a:t>Thursday's note, defended in pairs and then to the room.</a:t>
+              <a:t>You defend Thursday's note in pairs, then to the room.</a:t>
             </a:r>
           </a:p>
         </p:txBody>
@@ -16623,7 +16638,7 @@
                 </a:solidFill>
                 <a:latin typeface="Calibri"/>
               </a:rPr>
-              <a:t>Three timed design cases, answered aloud.</a:t>
+              <a:t>You answer three timed design cases aloud.</a:t>
             </a:r>
           </a:p>
         </p:txBody>
@@ -16811,7 +16826,7 @@
         <p:spPr>
           <a:xfrm>
             <a:off x="8237524" y="3277870"/>
-            <a:ext cx="3259226" cy="201676"/>
+            <a:ext cx="3259226" cy="366776"/>
           </a:xfrm>
           <a:prstGeom prst="rect">
             <a:avLst/>
@@ -16832,7 +16847,7 @@
                 </a:solidFill>
                 <a:latin typeface="Calibri"/>
               </a:rPr>
-              <a:t>The Kahoot, Saturday's paper and tonight's rerun.</a:t>
+              <a:t>The Kahoot, Saturday's paper and tonight's rerun close the week.</a:t>
             </a:r>
           </a:p>
         </p:txBody>
@@ -17482,7 +17497,7 @@
                 </a:solidFill>
                 <a:latin typeface="Calibri"/>
               </a:rPr>
-              <a:t>Choose one: a) ship to everyone now; b) keep the pilot small and wait, at about 12 visits a week; c) split the traffic in half until each checkout has about 300 visits; d) one visit in ten to the new checkout for a fortnight.</a:t>
+              <a:t>Choose one: a) ship to everyone now, on the 42 percent; b) keep the pilot small and wait for more weeks, at about 12 visits a week; c) split the traffic in half until each checkout has about 300 visits; d) one visit in ten to the new checkout for a fortnight, as a cautious rollout.</a:t>
             </a:r>
           </a:p>
         </p:txBody>
@@ -19848,7 +19863,7 @@
                 </a:solidFill>
                 <a:latin typeface="Calibri"/>
               </a:rPr>
-              <a:t>Who needs this answer, and which smaller questions lead to it?</a:t>
+              <a:t>Who will test the week's lines, and which four questions lead to tonight's rerun?</a:t>
             </a:r>
           </a:p>
         </p:txBody>
@@ -20122,7 +20137,7 @@
         <p:spPr>
           <a:xfrm>
             <a:off x="530352" y="3816096"/>
-            <a:ext cx="2645587" cy="904240"/>
+            <a:ext cx="2645587" cy="1076960"/>
           </a:xfrm>
           <a:prstGeom prst="roundRect">
             <a:avLst>
@@ -20232,7 +20247,7 @@
                 </a:solidFill>
                 <a:latin typeface="Calibri"/>
               </a:rPr>
-              <a:t>The Kahoot, eight items.</a:t>
+              <a:t>The Kahoot tests it in eight items.</a:t>
             </a:r>
           </a:p>
         </p:txBody>
@@ -20325,7 +20340,7 @@
         <p:spPr>
           <a:xfrm>
             <a:off x="3358819" y="3816096"/>
-            <a:ext cx="2645587" cy="904240"/>
+            <a:ext cx="2645587" cy="1076960"/>
           </a:xfrm>
           <a:prstGeom prst="roundRect">
             <a:avLst>
@@ -20414,7 +20429,7 @@
         <p:spPr>
           <a:xfrm>
             <a:off x="3523411" y="4250182"/>
-            <a:ext cx="2316403" cy="201676"/>
+            <a:ext cx="2316403" cy="366776"/>
           </a:xfrm>
           <a:prstGeom prst="rect">
             <a:avLst/>
@@ -20435,7 +20450,7 @@
                 </a:solidFill>
                 <a:latin typeface="Calibri"/>
               </a:rPr>
-              <a:t>The paper's format.</a:t>
+              <a:t>You hear the paper's format and marking.</a:t>
             </a:r>
           </a:p>
         </p:txBody>
@@ -20528,7 +20543,7 @@
         <p:spPr>
           <a:xfrm>
             <a:off x="6187287" y="3816096"/>
-            <a:ext cx="2645587" cy="904240"/>
+            <a:ext cx="2645587" cy="1076960"/>
           </a:xfrm>
           <a:prstGeom prst="roundRect">
             <a:avLst>
@@ -20617,7 +20632,7 @@
         <p:spPr>
           <a:xfrm>
             <a:off x="6351879" y="4250182"/>
-            <a:ext cx="2316403" cy="201676"/>
+            <a:ext cx="2316403" cy="366776"/>
           </a:xfrm>
           <a:prstGeom prst="rect">
             <a:avLst/>
@@ -20638,7 +20653,7 @@
                 </a:solidFill>
                 <a:latin typeface="Calibri"/>
               </a:rPr>
-              <a:t>Five, one per step.</a:t>
+              <a:t>Five lines, one per step, close the week.</a:t>
             </a:r>
           </a:p>
         </p:txBody>
@@ -20731,7 +20746,7 @@
         <p:spPr>
           <a:xfrm>
             <a:off x="9015755" y="3816096"/>
-            <a:ext cx="2645587" cy="904240"/>
+            <a:ext cx="2645587" cy="1076960"/>
           </a:xfrm>
           <a:prstGeom prst="roundRect">
             <a:avLst>
@@ -20826,7 +20841,7 @@
         <p:spPr>
           <a:xfrm>
             <a:off x="9180347" y="4250182"/>
-            <a:ext cx="2316403" cy="201676"/>
+            <a:ext cx="2316403" cy="366776"/>
           </a:xfrm>
           <a:prstGeom prst="rect">
             <a:avLst/>
@@ -20847,7 +20862,7 @@
                 </a:solidFill>
                 <a:latin typeface="Calibri"/>
               </a:rPr>
-              <a:t>Tonight's three tasks.</a:t>
+              <a:t>Tonight has three tasks, and one is a rerun.</a:t>
             </a:r>
           </a:p>
         </p:txBody>
@@ -21423,7 +21438,7 @@
                 </a:solidFill>
                 <a:latin typeface="Calibri"/>
               </a:rPr>
-              <a:t>Three items on the method, four design calls and Thursday's return question, ungraded.</a:t>
+              <a:t>The Kahoot is ungraded: three items on the method, four design calls and Thursday's return question.</a:t>
             </a:r>
           </a:p>
         </p:txBody>
@@ -22163,7 +22178,7 @@
                 </a:solidFill>
                 <a:latin typeface="Calibri"/>
               </a:rPr>
-              <a:t>Blanks from a word bank, pairs from a match table, statements judged with their reason, scenario sets, applied maths and ordering.</a:t>
+              <a:t>It mixes blanks from a word bank, pairs from a match table, statements judged with their reason, scenario sets, applied maths and ordering.</a:t>
             </a:r>
           </a:p>
         </p:txBody>
@@ -22596,7 +22611,7 @@
         <p:spPr>
           <a:xfrm>
             <a:off x="6388455" y="3303524"/>
-            <a:ext cx="2243251" cy="581406"/>
+            <a:ext cx="2243251" cy="763016"/>
           </a:xfrm>
           <a:prstGeom prst="rect">
             <a:avLst/>
@@ -22617,7 +22632,7 @@
                 </a:solidFill>
                 <a:latin typeface="Calibri"/>
               </a:rPr>
-              <a:t>The most-missed items first, then the week's interview questions as interview answers.</a:t>
+              <a:t>The most-missed items are discussed first, then the week's interview questions are answered aloud.</a:t>
             </a:r>
           </a:p>
         </p:txBody>
@@ -22823,7 +22838,7 @@
         <p:spPr>
           <a:xfrm>
             <a:off x="9216923" y="3303524"/>
-            <a:ext cx="2243251" cy="399796"/>
+            <a:ext cx="2243251" cy="581406"/>
           </a:xfrm>
           <a:prstGeom prst="rect">
             <a:avLst/>
@@ -22844,7 +22859,7 @@
                 </a:solidFill>
                 <a:latin typeface="Calibri"/>
               </a:rPr>
-              <a:t>A performance indicator for you and the team, with no ranking.</a:t>
+              <a:t>It is a performance indicator for you and the team, with no ranking.</a:t>
             </a:r>
           </a:p>
         </p:txBody>
@@ -24462,7 +24477,7 @@
                 </a:solidFill>
                 <a:latin typeface="Calibri"/>
               </a:rPr>
-              <a:t>The step the TA marked, on the practice export, with one line on what you will do differently.</a:t>
+              <a:t>Run the step the TA marked on the practice export, and write one line on what you will change.</a:t>
             </a:r>
           </a:p>
         </p:txBody>
@@ -24665,7 +24680,7 @@
                 </a:solidFill>
                 <a:latin typeface="Calibri"/>
               </a:rPr>
-              <a:t>The note's four parts and the p-value sentence; both are on Saturday's paper.</a:t>
+              <a:t>Write the note's four parts and the p-value sentence; both are on Saturday's paper.</a:t>
             </a:r>
           </a:p>
         </p:txBody>
@@ -24882,7 +24897,7 @@
         <p:spPr>
           <a:xfrm>
             <a:off x="530352" y="4103624"/>
-            <a:ext cx="11130991" cy="1121664"/>
+            <a:ext cx="11130991" cy="1639824"/>
           </a:xfrm>
           <a:prstGeom prst="roundRect">
             <a:avLst>
@@ -24935,7 +24950,7 @@
         </p:nvSpPr>
         <p:spPr>
           <a:xfrm>
-            <a:off x="758952" y="4435856"/>
+            <a:off x="758952" y="4694936"/>
             <a:ext cx="457200" cy="457200"/>
           </a:xfrm>
           <a:prstGeom prst="ellipse">
@@ -24987,7 +25002,7 @@
         </p:blipFill>
         <p:spPr>
           <a:xfrm>
-            <a:off x="868680" y="4545584"/>
+            <a:off x="868680" y="4804664"/>
             <a:ext cx="237744" cy="237744"/>
           </a:xfrm>
           <a:prstGeom prst="rect">
@@ -25039,7 +25054,7 @@
         <p:spPr>
           <a:xfrm>
             <a:off x="1399031" y="4469384"/>
-            <a:ext cx="9987991" cy="682752"/>
+            <a:ext cx="9987991" cy="1200912"/>
           </a:xfrm>
           <a:prstGeom prst="rect">
             <a:avLst/>
@@ -25059,7 +25074,7 @@
                 </a:solidFill>
                 <a:latin typeface="Calibri"/>
               </a:rPr>
-              <a:t>On Monday, Meera hears a note from someone who rebuilt every number in it alone this morning and reconciled it to Anand's books.</a:t>
+              <a:t>You have the method when its six steps, from the profile to the note, run in order under a clock and the note's caveat comes before the push, and tonight you rerun the one step the lab showed you do not own yet. On Monday, Meera hears Thursday's note from someone who ran the whole method alone this morning and held it against Marketing's pushes this afternoon.</a:t>
             </a:r>
           </a:p>
         </p:txBody>
@@ -26083,7 +26098,7 @@
                 </a:solidFill>
                 <a:latin typeface="Calibri"/>
               </a:rPr>
-              <a:t>Who needs this answer, and which smaller questions lead to it?</a:t>
+              <a:t>Who needs the note to hold, and which six questions test it?</a:t>
             </a:r>
           </a:p>
         </p:txBody>
@@ -26357,7 +26372,7 @@
         <p:spPr>
           <a:xfrm>
             <a:off x="530352" y="3816096"/>
-            <a:ext cx="1702765" cy="1076960"/>
+            <a:ext cx="1702765" cy="1249680"/>
           </a:xfrm>
           <a:prstGeom prst="roundRect">
             <a:avLst>
@@ -26467,7 +26482,7 @@
                 </a:solidFill>
                 <a:latin typeface="Calibri"/>
               </a:rPr>
-              <a:t>Four people, four weaknesses.</a:t>
+              <a:t>Each of four listens for one weakness.</a:t>
             </a:r>
           </a:p>
         </p:txBody>
@@ -26560,7 +26575,7 @@
         <p:spPr>
           <a:xfrm>
             <a:off x="2415997" y="3816096"/>
-            <a:ext cx="1702765" cy="1076960"/>
+            <a:ext cx="1702765" cy="1249680"/>
           </a:xfrm>
           <a:prstGeom prst="roundRect">
             <a:avLst>
@@ -26670,7 +26685,7 @@
                 </a:solidFill>
                 <a:latin typeface="Calibri"/>
               </a:rPr>
-              <a:t>Four parts, one order.</a:t>
+              <a:t>Four parts run in one fixed order.</a:t>
             </a:r>
           </a:p>
         </p:txBody>
@@ -26763,7 +26778,7 @@
         <p:spPr>
           <a:xfrm>
             <a:off x="4301642" y="3816096"/>
-            <a:ext cx="1702765" cy="1076960"/>
+            <a:ext cx="1702765" cy="1249680"/>
           </a:xfrm>
           <a:prstGeom prst="roundRect">
             <a:avLst>
@@ -26852,7 +26867,7 @@
         <p:spPr>
           <a:xfrm>
             <a:off x="4466234" y="4464812"/>
-            <a:ext cx="1373581" cy="366776"/>
+            <a:ext cx="1373581" cy="531876"/>
           </a:xfrm>
           <a:prstGeom prst="rect">
             <a:avLst/>
@@ -26873,7 +26888,7 @@
                 </a:solidFill>
                 <a:latin typeface="Calibri"/>
               </a:rPr>
-              <a:t>Fair questions with motives.</a:t>
+              <a:t>Each push is a fair question with a motive.</a:t>
             </a:r>
           </a:p>
         </p:txBody>
@@ -26966,7 +26981,7 @@
         <p:spPr>
           <a:xfrm>
             <a:off x="6187287" y="3816096"/>
-            <a:ext cx="1702765" cy="1076960"/>
+            <a:ext cx="1702765" cy="1249680"/>
           </a:xfrm>
           <a:prstGeom prst="roundRect">
             <a:avLst>
@@ -27055,7 +27070,7 @@
         <p:spPr>
           <a:xfrm>
             <a:off x="6351879" y="4464812"/>
-            <a:ext cx="1373581" cy="366776"/>
+            <a:ext cx="1373581" cy="531876"/>
           </a:xfrm>
           <a:prstGeom prst="rect">
             <a:avLst/>
@@ -27076,7 +27091,7 @@
                 </a:solidFill>
                 <a:latin typeface="Calibri"/>
               </a:rPr>
-              <a:t>Restate, bound, offer the test.</a:t>
+              <a:t>Restate it, bound it, and offer the test.</a:t>
             </a:r>
           </a:p>
         </p:txBody>
@@ -27169,7 +27184,7 @@
         <p:spPr>
           <a:xfrm>
             <a:off x="8072932" y="3816096"/>
-            <a:ext cx="1702765" cy="1076960"/>
+            <a:ext cx="1702765" cy="1249680"/>
           </a:xfrm>
           <a:prstGeom prst="roundRect">
             <a:avLst>
@@ -27279,7 +27294,7 @@
                 </a:solidFill>
                 <a:latin typeface="Calibri"/>
               </a:rPr>
-              <a:t>Pairs, then the room.</a:t>
+              <a:t>You defend in pairs, then to the room.</a:t>
             </a:r>
           </a:p>
         </p:txBody>
@@ -27372,7 +27387,7 @@
         <p:spPr>
           <a:xfrm>
             <a:off x="9958578" y="3816096"/>
-            <a:ext cx="1702765" cy="1076960"/>
+            <a:ext cx="1702765" cy="1249680"/>
           </a:xfrm>
           <a:prstGeom prst="roundRect">
             <a:avLst>
@@ -27467,7 +27482,7 @@
         <p:spPr>
           <a:xfrm>
             <a:off x="10123170" y="4464812"/>
-            <a:ext cx="1373581" cy="366776"/>
+            <a:ext cx="1373581" cy="531876"/>
           </a:xfrm>
           <a:prstGeom prst="rect">
             <a:avLst/>
@@ -27488,7 +27503,7 @@
                 </a:solidFill>
                 <a:latin typeface="Calibri"/>
               </a:rPr>
-              <a:t>Four answers, no score.</a:t>
+              <a:t>The card holds four answers and no score.</a:t>
             </a:r>
           </a:p>
         </p:txBody>
@@ -28228,7 +28243,7 @@
                 </a:solidFill>
                 <a:latin typeface="Calibri"/>
               </a:rPr>
-              <a:t>One page, two minutes, and what to do. She acts on the first line.</a:t>
+              <a:t>She wants one page in two minutes that says what to do, and she acts on its first line.</a:t>
             </a:r>
           </a:p>
         </p:txBody>
@@ -28455,7 +28470,7 @@
                 </a:solidFill>
                 <a:latin typeface="Calibri"/>
               </a:rPr>
-              <a:t>Defends the monsoon sale and the acquisition budget against your reading.</a:t>
+              <a:t>The lead defends the monsoon sale and the acquisition budget against your reading.</a:t>
             </a:r>
           </a:p>
         </p:txBody>
@@ -28661,7 +28676,7 @@
         <p:spPr>
           <a:xfrm>
             <a:off x="6388455" y="3303524"/>
-            <a:ext cx="2243251" cy="399796"/>
+            <a:ext cx="2243251" cy="581406"/>
           </a:xfrm>
           <a:prstGeom prst="rect">
             <a:avLst/>
@@ -28682,7 +28697,7 @@
                 </a:solidFill>
                 <a:latin typeface="Calibri"/>
               </a:rPr>
-              <a:t>Checks that every number matches the books and can be audited.</a:t>
+              <a:t>He checks that every number matches the books and can be audited.</a:t>
             </a:r>
           </a:p>
         </p:txBody>
@@ -28909,7 +28924,7 @@
                 </a:solidFill>
                 <a:latin typeface="Calibri"/>
               </a:rPr>
-              <a:t>Wants to know whether the paid tier is slipping and whom to protect first.</a:t>
+              <a:t>He wants to know whether the paid tier is slipping and whom to protect first.</a:t>
             </a:r>
           </a:p>
         </p:txBody>
@@ -29866,7 +29881,7 @@
                 </a:solidFill>
                 <a:latin typeface="Calibri"/>
               </a:rPr>
-              <a:t>One sentence, with the number and what it is out of.</a:t>
+              <a:t>One sentence carries the number and what it is out of.</a:t>
             </a:r>
           </a:p>
         </p:txBody>
@@ -30069,7 +30084,7 @@
                 </a:solidFill>
                 <a:latin typeface="Calibri"/>
               </a:rPr>
-              <a:t>What you computed, on how many, and how you checked it.</a:t>
+              <a:t>Say what you computed, on how many, and how you checked it.</a:t>
             </a:r>
           </a:p>
         </p:txBody>
@@ -30272,7 +30287,7 @@
                 </a:solidFill>
                 <a:latin typeface="Calibri"/>
               </a:rPr>
-              <a:t>The thing that would change the claim, said before anyone finds it.</a:t>
+              <a:t>Name what would change the claim before anyone finds it.</a:t>
             </a:r>
           </a:p>
         </p:txBody>
@@ -30475,7 +30490,7 @@
                 </a:solidFill>
                 <a:latin typeface="Calibri"/>
               </a:rPr>
-              <a:t>What to do, what it costs, and what would tell us more.</a:t>
+              <a:t>Close on what to do, what it costs, and what would tell us more.</a:t>
             </a:r>
           </a:p>
         </p:txBody>
@@ -31186,7 +31201,7 @@
       </p:sp>
       <p:pic>
         <p:nvPicPr>
-          <p:cNvPr id="9" name="mermaid diagram" descr="d24cc5219b206799.png"/>
+          <p:cNvPr id="9" name="mermaid diagram" descr="0e0c703932e10c36.png"/>
           <p:cNvPicPr>
             <a:picLocks noChangeAspect="1"/>
           </p:cNvPicPr>
@@ -31200,8 +31215,8 @@
         </p:blipFill>
         <p:spPr>
           <a:xfrm>
-            <a:off x="1325273" y="1682496"/>
-            <a:ext cx="3196483" cy="4517136"/>
+            <a:off x="1273023" y="1682496"/>
+            <a:ext cx="3300984" cy="4517136"/>
           </a:xfrm>
           <a:prstGeom prst="rect">
             <a:avLst/>
@@ -32448,7 +32463,7 @@
                 </a:solidFill>
                 <a:latin typeface="Georgia"/>
               </a:rPr>
-              <a:t>The sharpest push agrees with the numbers first</a:t>
+              <a:t>The answer that holds agrees with the numbers first</a:t>
             </a:r>
           </a:p>
         </p:txBody>
@@ -32490,7 +32505,7 @@
       </p:sp>
       <p:pic>
         <p:nvPicPr>
-          <p:cNvPr id="9" name="mermaid diagram" descr="c239db21db2649f3.png"/>
+          <p:cNvPr id="9" name="mermaid diagram" descr="8b4a7a0b9515533a.png"/>
           <p:cNvPicPr>
             <a:picLocks noChangeAspect="1"/>
           </p:cNvPicPr>
@@ -32505,7 +32520,7 @@
         <p:spPr>
           <a:xfrm>
             <a:off x="780897" y="1956816"/>
-            <a:ext cx="10629900" cy="1857375"/>
+            <a:ext cx="10629900" cy="2100262"/>
           </a:xfrm>
           <a:prstGeom prst="rect">
             <a:avLst/>
@@ -32520,8 +32535,8 @@
         </p:nvSpPr>
         <p:spPr>
           <a:xfrm>
-            <a:off x="530352" y="3960495"/>
-            <a:ext cx="11130991" cy="772160"/>
+            <a:off x="530352" y="4203382"/>
+            <a:ext cx="11130991" cy="1048512"/>
           </a:xfrm>
           <a:prstGeom prst="rect">
             <a:avLst/>
@@ -32546,7 +32561,7 @@
                 </a:solidFill>
                 <a:latin typeface="Calibri"/>
               </a:rPr>
-              <a:t>Folding loses the finding and overclaiming loses the room; the answer that holds agrees with Marketing's arithmetic and then shows who the blend was made of.</a:t>
+              <a:t>On invented figures, the blend rises 4.8 percent because half the sale's customers were members who spend more anyway, against 35 percent of the rest, while inside each segment the sale's customers spent 5.0 percent less.</a:t>
             </a:r>
           </a:p>
         </p:txBody>

</xml_diff>

<commit_message>
W01 D5: the rehearsal's staff instructions and the observation sheet say what to do in place of what never to do
Rehearsal S8, S10 and S18's speaker notes and the observation sheet's last line state how the TAs
tell each learner their marked step, how names are called and who hears the power arithmetic, as
positive instructions. The rehearsal deck rebuilt; the visible slides are unchanged.

Co-Authored-By: Claude Opus 5.5 <noreply@anthropic.com>
Claude-Session: https://claude.ai/code/session_01SjahrTf7jZ3ViL54dzqiBa
</commit_message>
<xml_diff>
--- a/content/W01/D5/slides/C2_W01_D05_rehearsal_STUDENT.pptx
+++ b/content/W01/D5/slides/C2_W01_D05_rehearsal_STUDENT.pptx
@@ -618,12 +618,12 @@
           </a:p>
           <a:p>
             <a:r>
-              <a:t>tell each of their learners, quietly and one at a time, the step the lab's observation sheet marked</a:t>
-            </a:r>
-          </a:p>
-          <a:p>
-            <a:r>
-              <a:t>for them, never aloud and never to a group.</a:t>
+              <a:t>tell each of their learners, one at a time and out of the others' hearing, the step the lab's</a:t>
+            </a:r>
+          </a:p>
+          <a:p>
+            <a:r>
+              <a:t>observation sheet marked for them.</a:t>
             </a:r>
           </a:p>
         </p:txBody>
@@ -768,7 +768,7 @@
           <a:lstStyle/>
           <a:p>
             <a:r>
-              <a:t>LIVE, 50 minutes. Call names from a shuffled list, never by volunteering. The room's push comes</a:t>
+              <a:t>LIVE, 50 minutes. Call names from a shuffled list and take no volunteers. The room's push comes</a:t>
             </a:r>
           </a:p>
           <a:p>
@@ -1523,7 +1523,7 @@
           </a:p>
           <a:p>
             <a:r>
-              <a:t>arithmetic is in the trainer's key, for a TA asked, never for the room.</a:t>
+              <a:t>arithmetic is in the trainer's key for a TA who is asked, and the room hears only the size.</a:t>
             </a:r>
           </a:p>
         </p:txBody>

</xml_diff>

<commit_message>
W01 D5: practice item 9 has one key, and case 3 gives the uneven-split size its own figures rest on
The practice set defines the branch that moved as the one carrying most of the segment's change, so
item 9's basket option no longer also fits; item 4's heading no longer echoes its key. Case 3 now
says an uneven split needs about 170 new-checkout visits beside two thousand or more current ones,
which is where B's 14 weeks and D's evidence come from, in the case file, the notes, rehearsal S18
and the key. The rehearsal deck rebuilt.

Co-Authored-By: Claude Opus 5.5 <noreply@anthropic.com>
Claude-Session: https://claude.ai/code/session_01SjahrTf7jZ3ViL54dzqiBa
</commit_message>
<xml_diff>
--- a/content/W01/D5/slides/C2_W01_D05_rehearsal_STUDENT.pptx
+++ b/content/W01/D5/slides/C2_W01_D05_rehearsal_STUDENT.pptx
@@ -1518,12 +1518,17 @@
           <a:lstStyle/>
           <a:p>
             <a:r>
-              <a:t>LIVE, 2 minutes, after the call-outs. D gathers more evidence than C in four times the time; the</a:t>
-            </a:r>
-          </a:p>
-          <a:p>
-            <a:r>
-              <a:t>arithmetic is in the trainer's key for a TA who is asked, and the room hears only the size.</a:t>
+              <a:t>LIVE, 2 minutes, after the call-outs. D gathers more evidence than C in four times the time, since</a:t>
+            </a:r>
+          </a:p>
+          <a:p>
+            <a:r>
+              <a:t>its 240 new-checkout visits beside 2,160 clear the 170 an uneven split needs; the arithmetic is in the</a:t>
+            </a:r>
+          </a:p>
+          <a:p>
+            <a:r>
+              <a:t>trainer's key for a TA who is asked, and the room hears only the two sizes.</a:t>
             </a:r>
           </a:p>
         </p:txBody>
@@ -18662,7 +18667,7 @@
         <p:spPr>
           <a:xfrm>
             <a:off x="530352" y="3419856"/>
-            <a:ext cx="11130991" cy="1121664"/>
+            <a:ext cx="11130991" cy="1380744"/>
           </a:xfrm>
           <a:prstGeom prst="roundRect">
             <a:avLst>
@@ -18715,7 +18720,7 @@
         </p:nvSpPr>
         <p:spPr>
           <a:xfrm>
-            <a:off x="758952" y="3752088"/>
+            <a:off x="758952" y="3881628"/>
             <a:ext cx="457200" cy="457200"/>
           </a:xfrm>
           <a:prstGeom prst="ellipse">
@@ -18767,7 +18772,7 @@
         </p:blipFill>
         <p:spPr>
           <a:xfrm>
-            <a:off x="868680" y="3861816"/>
+            <a:off x="868680" y="3991356"/>
             <a:ext cx="237744" cy="237744"/>
           </a:xfrm>
           <a:prstGeom prst="rect">
@@ -18819,7 +18824,7 @@
         <p:spPr>
           <a:xfrm>
             <a:off x="1399031" y="3785616"/>
-            <a:ext cx="9987991" cy="682752"/>
+            <a:ext cx="9987991" cy="941832"/>
           </a:xfrm>
           <a:prstGeom prst="rect">
             <a:avLst/>
@@ -18839,7 +18844,7 @@
                 </a:solidFill>
                 <a:latin typeface="Calibri"/>
               </a:rPr>
-              <a:t>c. Waiting at 12 visits a week takes about 14 weeks, and shipping now bets on five conversions. Switch to d, one visit in ten for a fortnight, when a worse checkout would lose money.</a:t>
+              <a:t>c. On an uneven split the new checkout needs about 170 visits beside the current one's thousands, so waiting at 12 visits a week takes about 14 weeks, and shipping now bets on five conversions. Switch to d, one visit in ten for a fortnight, when a worse checkout would lose money.</a:t>
             </a:r>
           </a:p>
         </p:txBody>

</xml_diff>